<commit_message>
CEA055: renumeração (sem aula de exercícios) e Aula 17 nova (qui-quadrado e t)
- Aulas 18-27 viram 17-26 (pastas, títulos, arquivos, referências cruzadas,
  aula_numero dos recursos externos); página "Aula 17 - Exercícios" removida.
- Aula 17 refeita: deck de 35 slides, pré-aula com puzzle e gabarito,
  Lista/Gabarito 17 reescritos, Tabela de Referências nova, notebook na ordem
  da aula, PDF de tabelas t e qui-quadrado (cauda superior) e pós-aula para casa.
- Aula 16: slides e notebook com as referências "Aula N" renumeradas.
- Slides 18-26 com PDF regerado no PowerPoint a partir do Drive.

Co-Authored-By: Claude Opus 5.5 <noreply@anthropic.com>
</commit_message>
<xml_diff>
--- a/content/2026-2/cea055-estatistica-probabilidade/16-propriedades-estimadores/Aula_16_Propriedades_Estimadores.pptx
+++ b/content/2026-2/cea055-estatistica-probabilidade/16-propriedades-estimadores/Aula_16_Propriedades_Estimadores.pptx
@@ -248,7 +248,7 @@
           <a:p>
             <a:fld id="{44623A65-BD25-40B6-8815-498297225DF7}" type="datetimeFigureOut">
               <a:rPr lang="pt-BR" smtClean="0"/>
-              <a:t>21/10/2026</a:t>
+              <a:t>28/10/2026</a:t>
             </a:fld>
             <a:endParaRPr lang="pt-BR" dirty="0"/>
           </a:p>
@@ -662,7 +662,7 @@
           <a:p>
             <a:fld id="{5B45E566-B383-4B2D-B951-1136FD38326E}" type="datetimeFigureOut">
               <a:rPr lang="pt-BR" smtClean="0"/>
-              <a:t>21/10/2026</a:t>
+              <a:t>28/10/2026</a:t>
             </a:fld>
             <a:endParaRPr lang="pt-BR" dirty="0"/>
           </a:p>
@@ -860,7 +860,7 @@
           <a:p>
             <a:fld id="{5B45E566-B383-4B2D-B951-1136FD38326E}" type="datetimeFigureOut">
               <a:rPr lang="pt-BR" smtClean="0"/>
-              <a:t>21/10/2026</a:t>
+              <a:t>28/10/2026</a:t>
             </a:fld>
             <a:endParaRPr lang="pt-BR" dirty="0"/>
           </a:p>
@@ -1068,7 +1068,7 @@
           <a:p>
             <a:fld id="{5B45E566-B383-4B2D-B951-1136FD38326E}" type="datetimeFigureOut">
               <a:rPr lang="pt-BR" smtClean="0"/>
-              <a:t>21/10/2026</a:t>
+              <a:t>28/10/2026</a:t>
             </a:fld>
             <a:endParaRPr lang="pt-BR" dirty="0"/>
           </a:p>
@@ -1266,7 +1266,7 @@
           <a:p>
             <a:fld id="{5B45E566-B383-4B2D-B951-1136FD38326E}" type="datetimeFigureOut">
               <a:rPr lang="pt-BR" smtClean="0"/>
-              <a:t>21/10/2026</a:t>
+              <a:t>28/10/2026</a:t>
             </a:fld>
             <a:endParaRPr lang="pt-BR" dirty="0"/>
           </a:p>
@@ -1541,7 +1541,7 @@
           <a:p>
             <a:fld id="{5B45E566-B383-4B2D-B951-1136FD38326E}" type="datetimeFigureOut">
               <a:rPr lang="pt-BR" smtClean="0"/>
-              <a:t>21/10/2026</a:t>
+              <a:t>28/10/2026</a:t>
             </a:fld>
             <a:endParaRPr lang="pt-BR" dirty="0"/>
           </a:p>
@@ -1806,7 +1806,7 @@
           <a:p>
             <a:fld id="{5B45E566-B383-4B2D-B951-1136FD38326E}" type="datetimeFigureOut">
               <a:rPr lang="pt-BR" smtClean="0"/>
-              <a:t>21/10/2026</a:t>
+              <a:t>28/10/2026</a:t>
             </a:fld>
             <a:endParaRPr lang="pt-BR" dirty="0"/>
           </a:p>
@@ -2218,7 +2218,7 @@
           <a:p>
             <a:fld id="{5B45E566-B383-4B2D-B951-1136FD38326E}" type="datetimeFigureOut">
               <a:rPr lang="pt-BR" smtClean="0"/>
-              <a:t>21/10/2026</a:t>
+              <a:t>28/10/2026</a:t>
             </a:fld>
             <a:endParaRPr lang="pt-BR" dirty="0"/>
           </a:p>
@@ -2359,7 +2359,7 @@
           <a:p>
             <a:fld id="{5B45E566-B383-4B2D-B951-1136FD38326E}" type="datetimeFigureOut">
               <a:rPr lang="pt-BR" smtClean="0"/>
-              <a:t>21/10/2026</a:t>
+              <a:t>28/10/2026</a:t>
             </a:fld>
             <a:endParaRPr lang="pt-BR" dirty="0"/>
           </a:p>
@@ -2472,7 +2472,7 @@
           <a:p>
             <a:fld id="{5B45E566-B383-4B2D-B951-1136FD38326E}" type="datetimeFigureOut">
               <a:rPr lang="pt-BR" smtClean="0"/>
-              <a:t>21/10/2026</a:t>
+              <a:t>28/10/2026</a:t>
             </a:fld>
             <a:endParaRPr lang="pt-BR" dirty="0"/>
           </a:p>
@@ -2783,7 +2783,7 @@
           <a:p>
             <a:fld id="{5B45E566-B383-4B2D-B951-1136FD38326E}" type="datetimeFigureOut">
               <a:rPr lang="pt-BR" smtClean="0"/>
-              <a:t>21/10/2026</a:t>
+              <a:t>28/10/2026</a:t>
             </a:fld>
             <a:endParaRPr lang="pt-BR" dirty="0"/>
           </a:p>
@@ -3071,7 +3071,7 @@
           <a:p>
             <a:fld id="{5B45E566-B383-4B2D-B951-1136FD38326E}" type="datetimeFigureOut">
               <a:rPr lang="pt-BR" smtClean="0"/>
-              <a:t>21/10/2026</a:t>
+              <a:t>28/10/2026</a:t>
             </a:fld>
             <a:endParaRPr lang="pt-BR" dirty="0"/>
           </a:p>
@@ -3336,7 +3336,7 @@
           <a:p>
             <a:fld id="{5B45E566-B383-4B2D-B951-1136FD38326E}" type="datetimeFigureOut">
               <a:rPr lang="pt-BR" smtClean="0"/>
-              <a:t>21/10/2026</a:t>
+              <a:t>28/10/2026</a:t>
             </a:fld>
             <a:endParaRPr lang="pt-BR" dirty="0"/>
           </a:p>
@@ -4151,7 +4151,7 @@
                     <m:sSup>
                       <m:sSupPr>
                         <m:ctrlPr>
-                          <a:rPr lang="pt-BR" sz="2400" b="1">
+                          <a:rPr lang="pt-BR" sz="2400" b="1" i="1">
                             <a:latin typeface="Cambria Math" panose="02040503050406030204" pitchFamily="18" charset="0"/>
                           </a:rPr>
                         </m:ctrlPr>
@@ -4210,7 +4210,7 @@
                     <m:sSup>
                       <m:sSupPr>
                         <m:ctrlPr>
-                          <a:rPr lang="pt-BR" sz="2400" b="1">
+                          <a:rPr lang="pt-BR" sz="2400" b="1" i="1">
                             <a:latin typeface="Cambria Math" panose="02040503050406030204" pitchFamily="18" charset="0"/>
                           </a:rPr>
                         </m:ctrlPr>
@@ -4282,7 +4282,7 @@
                     <m:sSup>
                       <m:sSupPr>
                         <m:ctrlPr>
-                          <a:rPr lang="pt-BR" sz="2400">
+                          <a:rPr lang="pt-BR" sz="2400" i="1">
                             <a:latin typeface="Cambria Math" panose="02040503050406030204" pitchFamily="18" charset="0"/>
                           </a:rPr>
                         </m:ctrlPr>
@@ -4546,7 +4546,7 @@
                     <m:sSup>
                       <m:sSupPr>
                         <m:ctrlPr>
-                          <a:rPr lang="pt-BR" sz="2400">
+                          <a:rPr lang="pt-BR" sz="2400" i="1">
                             <a:latin typeface="Cambria Math" panose="02040503050406030204" pitchFamily="18" charset="0"/>
                           </a:rPr>
                         </m:ctrlPr>
@@ -4556,7 +4556,7 @@
                           <m:accPr>
                             <m:chr m:val="̂"/>
                             <m:ctrlPr>
-                              <a:rPr lang="pt-BR" sz="2400">
+                              <a:rPr lang="pt-BR" sz="2400" i="1">
                                 <a:latin typeface="Cambria Math" panose="02040503050406030204" pitchFamily="18" charset="0"/>
                               </a:rPr>
                             </m:ctrlPr>
@@ -4604,7 +4604,7 @@
                     <m:sSup>
                       <m:sSupPr>
                         <m:ctrlPr>
-                          <a:rPr lang="pt-BR" sz="2400">
+                          <a:rPr lang="pt-BR" sz="2400" i="1">
                             <a:latin typeface="Cambria Math" panose="02040503050406030204" pitchFamily="18" charset="0"/>
                           </a:rPr>
                         </m:ctrlPr>
@@ -4652,7 +4652,7 @@
                       <m:barPr>
                         <m:pos m:val="top"/>
                         <m:ctrlPr>
-                          <a:rPr lang="pt-BR" sz="2400">
+                          <a:rPr lang="pt-BR" sz="2400" i="1">
                             <a:latin typeface="Cambria Math" panose="02040503050406030204" pitchFamily="18" charset="0"/>
                           </a:rPr>
                         </m:ctrlPr>
@@ -5060,7 +5060,7 @@
                     <m:sSup>
                       <m:sSupPr>
                         <m:ctrlPr>
-                          <a:rPr lang="pt-BR" sz="2400">
+                          <a:rPr lang="pt-BR" sz="2400" i="1">
                             <a:latin typeface="Cambria Math" panose="02040503050406030204" pitchFamily="18" charset="0"/>
                           </a:rPr>
                         </m:ctrlPr>
@@ -5108,7 +5108,7 @@
                     <m:sSup>
                       <m:sSupPr>
                         <m:ctrlPr>
-                          <a:rPr lang="pt-BR" sz="2400">
+                          <a:rPr lang="pt-BR" sz="2400" i="1">
                             <a:latin typeface="Cambria Math" panose="02040503050406030204" pitchFamily="18" charset="0"/>
                           </a:rPr>
                         </m:ctrlPr>
@@ -5118,7 +5118,7 @@
                           <m:accPr>
                             <m:chr m:val="̂"/>
                             <m:ctrlPr>
-                              <a:rPr lang="pt-BR" sz="2400">
+                              <a:rPr lang="pt-BR" sz="2400" i="1">
                                 <a:latin typeface="Cambria Math" panose="02040503050406030204" pitchFamily="18" charset="0"/>
                               </a:rPr>
                             </m:ctrlPr>
@@ -5173,7 +5173,7 @@
                     <m:sSup>
                       <m:sSupPr>
                         <m:ctrlPr>
-                          <a:rPr lang="pt-BR" sz="2400">
+                          <a:rPr lang="pt-BR" sz="2400" i="1">
                             <a:latin typeface="Cambria Math" panose="02040503050406030204" pitchFamily="18" charset="0"/>
                           </a:rPr>
                         </m:ctrlPr>
@@ -5493,7 +5493,7 @@
                     <m:sSup>
                       <m:sSupPr>
                         <m:ctrlPr>
-                          <a:rPr lang="pt-BR" sz="2400">
+                          <a:rPr lang="pt-BR" sz="2400" i="1">
                             <a:latin typeface="Cambria Math" panose="02040503050406030204" pitchFamily="18" charset="0"/>
                           </a:rPr>
                         </m:ctrlPr>
@@ -5696,7 +5696,7 @@
                     <m:sSup>
                       <m:sSupPr>
                         <m:ctrlPr>
-                          <a:rPr lang="pt-BR" sz="2400">
+                          <a:rPr lang="pt-BR" sz="2400" i="1">
                             <a:latin typeface="Cambria Math" panose="02040503050406030204" pitchFamily="18" charset="0"/>
                           </a:rPr>
                         </m:ctrlPr>
@@ -5706,7 +5706,7 @@
                           <m:accPr>
                             <m:chr m:val="̂"/>
                             <m:ctrlPr>
-                              <a:rPr lang="pt-BR" sz="2400">
+                              <a:rPr lang="pt-BR" sz="2400" i="1">
                                 <a:latin typeface="Cambria Math" panose="02040503050406030204" pitchFamily="18" charset="0"/>
                               </a:rPr>
                             </m:ctrlPr>
@@ -5747,7 +5747,7 @@
                     <m:sSup>
                       <m:sSupPr>
                         <m:ctrlPr>
-                          <a:rPr lang="pt-BR" sz="2400">
+                          <a:rPr lang="pt-BR" sz="2400" i="1">
                             <a:latin typeface="Cambria Math" panose="02040503050406030204" pitchFamily="18" charset="0"/>
                           </a:rPr>
                         </m:ctrlPr>
@@ -6164,8 +6164,8 @@
           </a:graphicData>
         </a:graphic>
       </p:graphicFrame>
-      <mc:AlternateContent xmlns:mc="http://schemas.openxmlformats.org/markup-compatibility/2006">
-        <mc:Choice xmlns:a14="http://schemas.microsoft.com/office/drawing/2010/main" Requires="a14">
+      <mc:AlternateContent xmlns:mc="http://schemas.openxmlformats.org/markup-compatibility/2006" xmlns:a14="http://schemas.microsoft.com/office/drawing/2010/main">
+        <mc:Choice Requires="a14">
           <p:sp>
             <p:nvSpPr>
               <p:cNvPr id="6" name="TextBox 5"/>
@@ -6214,7 +6214,7 @@
                     <m:sSup>
                       <m:sSupPr>
                         <m:ctrlPr>
-                          <a:rPr lang="pt-BR" sz="2400">
+                          <a:rPr lang="pt-BR" sz="2400" i="1">
                             <a:latin typeface="Cambria Math" panose="02040503050406030204" pitchFamily="18" charset="0"/>
                           </a:rPr>
                         </m:ctrlPr>
@@ -6224,7 +6224,7 @@
                           <m:accPr>
                             <m:chr m:val="̂"/>
                             <m:ctrlPr>
-                              <a:rPr lang="pt-BR" sz="2400">
+                              <a:rPr lang="pt-BR" sz="2400" i="1">
                                 <a:latin typeface="Cambria Math" panose="02040503050406030204" pitchFamily="18" charset="0"/>
                               </a:rPr>
                             </m:ctrlPr>
@@ -6287,7 +6287,7 @@
                     <m:sSup>
                       <m:sSupPr>
                         <m:ctrlPr>
-                          <a:rPr lang="pt-BR" sz="2400">
+                          <a:rPr lang="pt-BR" sz="2400" i="1">
                             <a:latin typeface="Cambria Math" panose="02040503050406030204" pitchFamily="18" charset="0"/>
                           </a:rPr>
                         </m:ctrlPr>
@@ -6328,7 +6328,7 @@
                     <m:sSup>
                       <m:sSupPr>
                         <m:ctrlPr>
-                          <a:rPr lang="pt-BR" sz="2400">
+                          <a:rPr lang="pt-BR" sz="2400" i="1">
                             <a:latin typeface="Cambria Math" panose="02040503050406030204" pitchFamily="18" charset="0"/>
                           </a:rPr>
                         </m:ctrlPr>
@@ -6360,7 +6360,7 @@
             </p:txBody>
           </p:sp>
         </mc:Choice>
-        <mc:Fallback>
+        <mc:Fallback xmlns="">
           <p:sp>
             <p:nvSpPr>
               <p:cNvPr id="6" name="TextBox 5"/>
@@ -6459,8 +6459,8 @@
           </a:p>
         </p:txBody>
       </p:sp>
-      <mc:AlternateContent xmlns:mc="http://schemas.openxmlformats.org/markup-compatibility/2006">
-        <mc:Choice xmlns:a14="http://schemas.microsoft.com/office/drawing/2010/main" Requires="a14">
+      <mc:AlternateContent xmlns:mc="http://schemas.openxmlformats.org/markup-compatibility/2006" xmlns:a14="http://schemas.microsoft.com/office/drawing/2010/main">
+        <mc:Choice Requires="a14">
           <p:sp>
             <p:nvSpPr>
               <p:cNvPr id="4" name="TextBox 3"/>
@@ -6505,7 +6505,7 @@
                     <m:sSup>
                       <m:sSupPr>
                         <m:ctrlPr>
-                          <a:rPr lang="pt-BR" sz="2400" b="1">
+                          <a:rPr lang="pt-BR" sz="2400" b="1" i="1">
                             <a:latin typeface="Cambria Math" panose="02040503050406030204" pitchFamily="18" charset="0"/>
                           </a:rPr>
                         </m:ctrlPr>
@@ -6556,7 +6556,7 @@
                     <m:sSup>
                       <m:sSupPr>
                         <m:ctrlPr>
-                          <a:rPr lang="pt-BR" sz="2400">
+                          <a:rPr lang="pt-BR" sz="2400" i="1">
                             <a:latin typeface="Cambria Math" panose="02040503050406030204" pitchFamily="18" charset="0"/>
                           </a:rPr>
                         </m:ctrlPr>
@@ -6597,7 +6597,7 @@
                     <m:sSup>
                       <m:sSupPr>
                         <m:ctrlPr>
-                          <a:rPr lang="pt-BR" sz="2400">
+                          <a:rPr lang="pt-BR" sz="2400" i="1">
                             <a:latin typeface="Cambria Math" panose="02040503050406030204" pitchFamily="18" charset="0"/>
                           </a:rPr>
                         </m:ctrlPr>
@@ -6670,7 +6670,7 @@
                     <m:sSup>
                       <m:sSupPr>
                         <m:ctrlPr>
-                          <a:rPr lang="pt-BR" sz="2400">
+                          <a:rPr lang="pt-BR" sz="2400" i="1">
                             <a:latin typeface="Cambria Math" panose="02040503050406030204" pitchFamily="18" charset="0"/>
                           </a:rPr>
                         </m:ctrlPr>
@@ -6680,7 +6680,7 @@
                           <m:accPr>
                             <m:chr m:val="̂"/>
                             <m:ctrlPr>
-                              <a:rPr lang="pt-BR" sz="2400">
+                              <a:rPr lang="pt-BR" sz="2400" i="1">
                                 <a:latin typeface="Cambria Math" panose="02040503050406030204" pitchFamily="18" charset="0"/>
                               </a:rPr>
                             </m:ctrlPr>
@@ -6755,7 +6755,7 @@
                     <m:sSup>
                       <m:sSupPr>
                         <m:ctrlPr>
-                          <a:rPr lang="pt-BR" sz="2400">
+                          <a:rPr lang="pt-BR" sz="2400" i="1">
                             <a:latin typeface="Cambria Math" panose="02040503050406030204" pitchFamily="18" charset="0"/>
                           </a:rPr>
                         </m:ctrlPr>
@@ -7039,19 +7039,7 @@
                       <a:rPr lang="pt-BR" sz="2400">
                         <a:latin typeface="Cambria Math"/>
                       </a:rPr>
-                      <m:t>(</m:t>
-                    </m:r>
-                    <m:r>
-                      <a:rPr lang="pt-BR" sz="2400">
-                        <a:latin typeface="Cambria Math"/>
-                      </a:rPr>
-                      <m:t>1</m:t>
-                    </m:r>
-                    <m:r>
-                      <a:rPr lang="pt-BR" sz="2400">
-                        <a:latin typeface="Cambria Math"/>
-                      </a:rPr>
-                      <m:t>−</m:t>
+                      <m:t>(1−</m:t>
                     </m:r>
                     <m:f>
                       <m:fPr>
@@ -7114,13 +7102,7 @@
                       <a:rPr lang="pt-BR" sz="2000">
                         <a:latin typeface="Cambria Math"/>
                       </a:rPr>
-                      <m:t>=</m:t>
-                    </m:r>
-                    <m:r>
-                      <a:rPr lang="pt-BR" sz="2000">
-                        <a:latin typeface="Cambria Math"/>
-                      </a:rPr>
-                      <m:t>2</m:t>
+                      <m:t>=2</m:t>
                     </m:r>
                   </m:oMath>
                 </a14:m>
@@ -7140,7 +7122,7 @@
             </p:txBody>
           </p:sp>
         </mc:Choice>
-        <mc:Fallback>
+        <mc:Fallback xmlns="">
           <p:sp>
             <p:nvSpPr>
               <p:cNvPr id="4" name="TextBox 3"/>
@@ -7878,8 +7860,8 @@
           </a:p>
         </p:txBody>
       </p:sp>
-      <mc:AlternateContent xmlns:mc="http://schemas.openxmlformats.org/markup-compatibility/2006">
-        <mc:Choice xmlns:a14="http://schemas.microsoft.com/office/drawing/2010/main" Requires="a14">
+      <mc:AlternateContent xmlns:mc="http://schemas.openxmlformats.org/markup-compatibility/2006" xmlns:a14="http://schemas.microsoft.com/office/drawing/2010/main">
+        <mc:Choice Requires="a14">
           <p:sp>
             <p:nvSpPr>
               <p:cNvPr id="4" name="TextBox 3"/>
@@ -8470,7 +8452,7 @@
             </p:txBody>
           </p:sp>
         </mc:Choice>
-        <mc:Fallback>
+        <mc:Fallback xmlns="">
           <p:sp>
             <p:nvSpPr>
               <p:cNvPr id="4" name="TextBox 3"/>
@@ -8623,7 +8605,7 @@
                       <m:accPr>
                         <m:chr m:val="̂"/>
                         <m:ctrlPr>
-                          <a:rPr lang="pt-BR" sz="2400">
+                          <a:rPr lang="pt-BR" sz="2400" i="1">
                             <a:latin typeface="Cambria Math" panose="02040503050406030204" pitchFamily="18" charset="0"/>
                           </a:rPr>
                         </m:ctrlPr>
@@ -9132,7 +9114,7 @@
                       <m:accPr>
                         <m:chr m:val="̂"/>
                         <m:ctrlPr>
-                          <a:rPr lang="pt-BR" sz="2400" b="1">
+                          <a:rPr lang="pt-BR" sz="2400" b="1" i="1">
                             <a:latin typeface="Cambria Math" panose="02040503050406030204" pitchFamily="18" charset="0"/>
                           </a:rPr>
                         </m:ctrlPr>
@@ -9208,7 +9190,7 @@
                       <m:accPr>
                         <m:chr m:val="̂"/>
                         <m:ctrlPr>
-                          <a:rPr lang="pt-BR" sz="2400">
+                          <a:rPr lang="pt-BR" sz="2400" i="1">
                             <a:latin typeface="Cambria Math" panose="02040503050406030204" pitchFamily="18" charset="0"/>
                           </a:rPr>
                         </m:ctrlPr>
@@ -9248,7 +9230,7 @@
                       <m:accPr>
                         <m:chr m:val="̂"/>
                         <m:ctrlPr>
-                          <a:rPr lang="pt-BR" sz="2400">
+                          <a:rPr lang="pt-BR" sz="2400" i="1">
                             <a:latin typeface="Cambria Math" panose="02040503050406030204" pitchFamily="18" charset="0"/>
                           </a:rPr>
                         </m:ctrlPr>
@@ -9628,7 +9610,7 @@
                       <m:accPr>
                         <m:chr m:val="̂"/>
                         <m:ctrlPr>
-                          <a:rPr lang="pt-BR" sz="2000">
+                          <a:rPr lang="pt-BR" sz="2000" i="1">
                             <a:latin typeface="Cambria Math" panose="02040503050406030204" pitchFamily="18" charset="0"/>
                           </a:rPr>
                         </m:ctrlPr>
@@ -9665,7 +9647,7 @@
                       <m:accPr>
                         <m:chr m:val="̂"/>
                         <m:ctrlPr>
-                          <a:rPr lang="pt-BR" sz="2400">
+                          <a:rPr lang="pt-BR" sz="2400" i="1">
                             <a:latin typeface="Cambria Math" panose="02040503050406030204" pitchFamily="18" charset="0"/>
                           </a:rPr>
                         </m:ctrlPr>
@@ -9695,7 +9677,7 @@
                       <m:accPr>
                         <m:chr m:val="̂"/>
                         <m:ctrlPr>
-                          <a:rPr lang="pt-BR" sz="2400">
+                          <a:rPr lang="pt-BR" sz="2400" i="1">
                             <a:latin typeface="Cambria Math" panose="02040503050406030204" pitchFamily="18" charset="0"/>
                           </a:rPr>
                         </m:ctrlPr>
@@ -10093,7 +10075,7 @@
                       <m:accPr>
                         <m:chr m:val="̂"/>
                         <m:ctrlPr>
-                          <a:rPr lang="pt-BR" sz="2400">
+                          <a:rPr lang="pt-BR" sz="2400" i="1">
                             <a:latin typeface="Cambria Math" panose="02040503050406030204" pitchFamily="18" charset="0"/>
                           </a:rPr>
                         </m:ctrlPr>
@@ -10119,7 +10101,7 @@
                       <m:barPr>
                         <m:pos m:val="top"/>
                         <m:ctrlPr>
-                          <a:rPr lang="pt-BR" sz="2400">
+                          <a:rPr lang="pt-BR" sz="2400" i="1">
                             <a:latin typeface="Cambria Math" panose="02040503050406030204" pitchFamily="18" charset="0"/>
                           </a:rPr>
                         </m:ctrlPr>
@@ -10345,7 +10327,7 @@
                     <m:sSup>
                       <m:sSupPr>
                         <m:ctrlPr>
-                          <a:rPr lang="pt-BR" sz="2400" b="1">
+                          <a:rPr lang="pt-BR" sz="2400" b="1" i="1">
                             <a:latin typeface="Cambria Math" panose="02040503050406030204" pitchFamily="18" charset="0"/>
                           </a:rPr>
                         </m:ctrlPr>
@@ -10403,7 +10385,7 @@
                     <m:sSup>
                       <m:sSupPr>
                         <m:ctrlPr>
-                          <a:rPr lang="pt-BR" sz="2400">
+                          <a:rPr lang="pt-BR" sz="2400" i="1">
                             <a:latin typeface="Cambria Math" panose="02040503050406030204" pitchFamily="18" charset="0"/>
                           </a:rPr>
                         </m:ctrlPr>
@@ -10429,13 +10411,7 @@
                       <a:rPr lang="pt-BR" sz="2400">
                         <a:latin typeface="Cambria Math"/>
                       </a:rPr>
-                      <m:t>=</m:t>
-                    </m:r>
-                    <m:r>
-                      <a:rPr lang="pt-BR" sz="2400">
-                        <a:latin typeface="Cambria Math"/>
-                      </a:rPr>
-                      <m:t>64</m:t>
+                      <m:t>=64</m:t>
                     </m:r>
                   </m:oMath>
                 </a14:m>
@@ -10448,7 +10424,7 @@
                     <m:sSup>
                       <m:sSupPr>
                         <m:ctrlPr>
-                          <a:rPr lang="pt-BR" sz="2400">
+                          <a:rPr lang="pt-BR" sz="2400" i="1">
                             <a:latin typeface="Cambria Math" panose="02040503050406030204" pitchFamily="18" charset="0"/>
                           </a:rPr>
                         </m:ctrlPr>
@@ -10481,7 +10457,7 @@
                     <m:sSup>
                       <m:sSupPr>
                         <m:ctrlPr>
-                          <a:rPr lang="pt-BR" sz="2400">
+                          <a:rPr lang="pt-BR" sz="2400" i="1">
                             <a:latin typeface="Cambria Math" panose="02040503050406030204" pitchFamily="18" charset="0"/>
                           </a:rPr>
                         </m:ctrlPr>
@@ -10521,13 +10497,7 @@
                       <a:rPr lang="pt-BR" sz="2400">
                         <a:latin typeface="Cambria Math"/>
                       </a:rPr>
-                      <m:t>−</m:t>
-                    </m:r>
-                    <m:r>
-                      <a:rPr lang="pt-BR" sz="2400">
-                        <a:latin typeface="Cambria Math"/>
-                      </a:rPr>
-                      <m:t>1</m:t>
+                      <m:t>−1</m:t>
                     </m:r>
                   </m:oMath>
                 </a14:m>
@@ -10540,7 +10510,7 @@
                     <m:sSup>
                       <m:sSupPr>
                         <m:ctrlPr>
-                          <a:rPr lang="pt-BR" sz="2400">
+                          <a:rPr lang="pt-BR" sz="2400" i="1">
                             <a:latin typeface="Cambria Math" panose="02040503050406030204" pitchFamily="18" charset="0"/>
                           </a:rPr>
                         </m:ctrlPr>
@@ -10927,7 +10897,7 @@
                     <m:sSup>
                       <m:sSupPr>
                         <m:ctrlPr>
-                          <a:rPr lang="pt-BR" sz="2400">
+                          <a:rPr lang="pt-BR" sz="2400" i="1">
                             <a:latin typeface="Cambria Math" panose="02040503050406030204" pitchFamily="18" charset="0"/>
                           </a:rPr>
                         </m:ctrlPr>
@@ -10964,7 +10934,7 @@
                     <m:sSup>
                       <m:sSupPr>
                         <m:ctrlPr>
-                          <a:rPr lang="pt-BR" sz="2400">
+                          <a:rPr lang="pt-BR" sz="2400" i="1">
                             <a:latin typeface="Cambria Math" panose="02040503050406030204" pitchFamily="18" charset="0"/>
                           </a:rPr>
                         </m:ctrlPr>
@@ -11184,7 +11154,7 @@
                     <m:sSup>
                       <m:sSupPr>
                         <m:ctrlPr>
-                          <a:rPr lang="pt-BR" sz="2400">
+                          <a:rPr lang="pt-BR" sz="2400" i="1">
                             <a:latin typeface="Cambria Math" panose="02040503050406030204" pitchFamily="18" charset="0"/>
                           </a:rPr>
                         </m:ctrlPr>
@@ -11245,7 +11215,7 @@
                       <m:accPr>
                         <m:chr m:val="̂"/>
                         <m:ctrlPr>
-                          <a:rPr lang="pt-BR" sz="2400" b="1">
+                          <a:rPr lang="pt-BR" sz="2400" b="1" i="1">
                             <a:latin typeface="Cambria Math" panose="02040503050406030204" pitchFamily="18" charset="0"/>
                           </a:rPr>
                         </m:ctrlPr>
@@ -11285,7 +11255,7 @@
                       <m:barPr>
                         <m:pos m:val="top"/>
                         <m:ctrlPr>
-                          <a:rPr lang="pt-BR" sz="2400">
+                          <a:rPr lang="pt-BR" sz="2400" i="1">
                             <a:latin typeface="Cambria Math" panose="02040503050406030204" pitchFamily="18" charset="0"/>
                           </a:rPr>
                         </m:ctrlPr>
@@ -11311,7 +11281,7 @@
                       <m:accPr>
                         <m:chr m:val="̂"/>
                         <m:ctrlPr>
-                          <a:rPr lang="pt-BR" sz="2400">
+                          <a:rPr lang="pt-BR" sz="2400" i="1">
                             <a:latin typeface="Cambria Math" panose="02040503050406030204" pitchFamily="18" charset="0"/>
                           </a:rPr>
                         </m:ctrlPr>
@@ -11362,7 +11332,7 @@
                       <m:barPr>
                         <m:pos m:val="top"/>
                         <m:ctrlPr>
-                          <a:rPr lang="pt-BR" sz="2400">
+                          <a:rPr lang="pt-BR" sz="2400" i="1">
                             <a:latin typeface="Cambria Math" panose="02040503050406030204" pitchFamily="18" charset="0"/>
                           </a:rPr>
                         </m:ctrlPr>
@@ -11709,7 +11679,7 @@
                     <m:sSup>
                       <m:sSupPr>
                         <m:ctrlPr>
-                          <a:rPr lang="pt-BR" sz="2400">
+                          <a:rPr lang="pt-BR" sz="2400" i="1">
                             <a:latin typeface="Cambria Math" panose="02040503050406030204" pitchFamily="18" charset="0"/>
                           </a:rPr>
                         </m:ctrlPr>
@@ -11804,7 +11774,7 @@
                     <m:sSup>
                       <m:sSupPr>
                         <m:ctrlPr>
-                          <a:rPr lang="pt-BR" sz="2400">
+                          <a:rPr lang="pt-BR" sz="2400" i="1">
                             <a:latin typeface="Cambria Math" panose="02040503050406030204" pitchFamily="18" charset="0"/>
                           </a:rPr>
                         </m:ctrlPr>
@@ -11837,7 +11807,7 @@
                     <m:sSup>
                       <m:sSupPr>
                         <m:ctrlPr>
-                          <a:rPr lang="pt-BR" sz="2400">
+                          <a:rPr lang="pt-BR" sz="2400" i="1">
                             <a:latin typeface="Cambria Math" panose="02040503050406030204" pitchFamily="18" charset="0"/>
                           </a:rPr>
                         </m:ctrlPr>
@@ -13050,7 +13020,7 @@
                       <m:accPr>
                         <m:chr m:val="̂"/>
                         <m:ctrlPr>
-                          <a:rPr lang="pt-BR" sz="2400">
+                          <a:rPr lang="pt-BR" sz="2400" i="1">
                             <a:latin typeface="Cambria Math" panose="02040503050406030204" pitchFamily="18" charset="0"/>
                           </a:rPr>
                         </m:ctrlPr>
@@ -13075,7 +13045,7 @@
                     <m:sSup>
                       <m:sSupPr>
                         <m:ctrlPr>
-                          <a:rPr lang="pt-BR" sz="2400">
+                          <a:rPr lang="pt-BR" sz="2400" i="1">
                             <a:latin typeface="Cambria Math" panose="02040503050406030204" pitchFamily="18" charset="0"/>
                           </a:rPr>
                         </m:ctrlPr>
@@ -13085,7 +13055,7 @@
                           <m:accPr>
                             <m:chr m:val="̂"/>
                             <m:ctrlPr>
-                              <a:rPr lang="pt-BR" sz="2400">
+                              <a:rPr lang="pt-BR" sz="2400" i="1">
                                 <a:latin typeface="Cambria Math" panose="02040503050406030204" pitchFamily="18" charset="0"/>
                               </a:rPr>
                             </m:ctrlPr>
@@ -13240,7 +13210,7 @@
                       <m:accPr>
                         <m:chr m:val="̂"/>
                         <m:ctrlPr>
-                          <a:rPr lang="pt-BR" sz="2400">
+                          <a:rPr lang="pt-BR" sz="2400" i="1">
                             <a:latin typeface="Cambria Math" panose="02040503050406030204" pitchFamily="18" charset="0"/>
                           </a:rPr>
                         </m:ctrlPr>
@@ -13273,7 +13243,7 @@
                     <m:sSup>
                       <m:sSupPr>
                         <m:ctrlPr>
-                          <a:rPr lang="pt-BR" sz="2400">
+                          <a:rPr lang="pt-BR" sz="2400" i="1">
                             <a:latin typeface="Cambria Math" panose="02040503050406030204" pitchFamily="18" charset="0"/>
                           </a:rPr>
                         </m:ctrlPr>
@@ -13283,7 +13253,7 @@
                           <m:accPr>
                             <m:chr m:val="̂"/>
                             <m:ctrlPr>
-                              <a:rPr lang="pt-BR" sz="2400">
+                              <a:rPr lang="pt-BR" sz="2400" i="1">
                                 <a:latin typeface="Cambria Math" panose="02040503050406030204" pitchFamily="18" charset="0"/>
                               </a:rPr>
                             </m:ctrlPr>
@@ -13554,7 +13524,7 @@
                       <m:barPr>
                         <m:pos m:val="top"/>
                         <m:ctrlPr>
-                          <a:rPr lang="pt-BR" sz="2400" b="1">
+                          <a:rPr lang="pt-BR" sz="2400" b="1" i="1">
                             <a:latin typeface="Cambria Math" panose="02040503050406030204" pitchFamily="18" charset="0"/>
                           </a:rPr>
                         </m:ctrlPr>
@@ -13580,7 +13550,7 @@
                       <m:accPr>
                         <m:chr m:val="̂"/>
                         <m:ctrlPr>
-                          <a:rPr lang="pt-BR" sz="2400" b="1">
+                          <a:rPr lang="pt-BR" sz="2400" b="1" i="1">
                             <a:latin typeface="Cambria Math" panose="02040503050406030204" pitchFamily="18" charset="0"/>
                           </a:rPr>
                         </m:ctrlPr>
@@ -13605,7 +13575,7 @@
                     <m:sSup>
                       <m:sSupPr>
                         <m:ctrlPr>
-                          <a:rPr lang="pt-BR" sz="2400" b="1">
+                          <a:rPr lang="pt-BR" sz="2400" b="1" i="1">
                             <a:latin typeface="Cambria Math" panose="02040503050406030204" pitchFamily="18" charset="0"/>
                           </a:rPr>
                         </m:ctrlPr>
@@ -13679,8 +13649,8 @@
           </p:sp>
         </mc:Fallback>
       </mc:AlternateContent>
-      <mc:AlternateContent xmlns:mc="http://schemas.openxmlformats.org/markup-compatibility/2006">
-        <mc:Choice xmlns:a14="http://schemas.microsoft.com/office/drawing/2010/main" Requires="a14">
+      <mc:AlternateContent xmlns:mc="http://schemas.openxmlformats.org/markup-compatibility/2006" xmlns:a14="http://schemas.microsoft.com/office/drawing/2010/main">
+        <mc:Choice Requires="a14">
           <p:graphicFrame>
             <p:nvGraphicFramePr>
               <p:cNvPr id="5" name="Table 4"/>
@@ -14165,7 +14135,7 @@
             </a:graphic>
           </p:graphicFrame>
         </mc:Choice>
-        <mc:Fallback>
+        <mc:Fallback xmlns="">
           <p:graphicFrame>
             <p:nvGraphicFramePr>
               <p:cNvPr id="5" name="Table 4"/>
@@ -14498,8 +14468,8 @@
           </p:graphicFrame>
         </mc:Fallback>
       </mc:AlternateContent>
-      <mc:AlternateContent xmlns:mc="http://schemas.openxmlformats.org/markup-compatibility/2006">
-        <mc:Choice xmlns:a14="http://schemas.microsoft.com/office/drawing/2010/main" Requires="a14">
+      <mc:AlternateContent xmlns:mc="http://schemas.openxmlformats.org/markup-compatibility/2006" xmlns:a14="http://schemas.microsoft.com/office/drawing/2010/main">
+        <mc:Choice Requires="a14">
           <p:sp>
             <p:nvSpPr>
               <p:cNvPr id="6" name="TextBox 5"/>
@@ -14575,7 +14545,7 @@
                       <m:barPr>
                         <m:pos m:val="top"/>
                         <m:ctrlPr>
-                          <a:rPr lang="pt-BR" sz="2400">
+                          <a:rPr lang="pt-BR" sz="2400" i="1">
                             <a:latin typeface="Cambria Math" panose="02040503050406030204" pitchFamily="18" charset="0"/>
                           </a:rPr>
                         </m:ctrlPr>
@@ -14649,7 +14619,7 @@
                     <m:sSup>
                       <m:sSupPr>
                         <m:ctrlPr>
-                          <a:rPr lang="pt-BR" sz="2400">
+                          <a:rPr lang="pt-BR" sz="2400" i="1">
                             <a:latin typeface="Cambria Math" panose="02040503050406030204" pitchFamily="18" charset="0"/>
                           </a:rPr>
                         </m:ctrlPr>
@@ -14659,7 +14629,7 @@
                           <m:accPr>
                             <m:chr m:val="̂"/>
                             <m:ctrlPr>
-                              <a:rPr lang="pt-BR" sz="2400">
+                              <a:rPr lang="pt-BR" sz="2400" i="1">
                                 <a:latin typeface="Cambria Math" panose="02040503050406030204" pitchFamily="18" charset="0"/>
                               </a:rPr>
                             </m:ctrlPr>
@@ -14781,7 +14751,7 @@
             </p:txBody>
           </p:sp>
         </mc:Choice>
-        <mc:Fallback>
+        <mc:Fallback xmlns="">
           <p:sp>
             <p:nvSpPr>
               <p:cNvPr id="6" name="TextBox 5"/>
@@ -14880,8 +14850,8 @@
           </a:p>
         </p:txBody>
       </p:sp>
-      <mc:AlternateContent xmlns:mc="http://schemas.openxmlformats.org/markup-compatibility/2006" xmlns:a14="http://schemas.microsoft.com/office/drawing/2010/main">
-        <mc:Choice Requires="a14">
+      <mc:AlternateContent xmlns:mc="http://schemas.openxmlformats.org/markup-compatibility/2006">
+        <mc:Choice xmlns:a14="http://schemas.microsoft.com/office/drawing/2010/main" Requires="a14">
           <p:sp>
             <p:nvSpPr>
               <p:cNvPr id="4" name="TextBox 3"/>
@@ -14891,7 +14861,7 @@
             <p:spPr>
               <a:xfrm>
                 <a:off x="729287" y="467833"/>
-                <a:ext cx="10733426" cy="5900000"/>
+                <a:ext cx="10733426" cy="4277838"/>
               </a:xfrm>
               <a:prstGeom prst="rect">
                 <a:avLst/>
@@ -14931,7 +14901,7 @@
                     <m:sSup>
                       <m:sSupPr>
                         <m:ctrlPr>
-                          <a:rPr lang="pt-BR" sz="2400">
+                          <a:rPr lang="pt-BR" sz="2400" i="1">
                             <a:latin typeface="Cambria Math" panose="02040503050406030204" pitchFamily="18" charset="0"/>
                           </a:rPr>
                         </m:ctrlPr>
@@ -14989,13 +14959,7 @@
                               <a:rPr lang="pt-BR" sz="2400">
                                 <a:latin typeface="Cambria Math"/>
                               </a:rPr>
-                              <m:t>=</m:t>
-                            </m:r>
-                            <m:r>
-                              <a:rPr lang="pt-BR" sz="2400">
-                                <a:latin typeface="Cambria Math"/>
-                              </a:rPr>
-                              <m:t>1</m:t>
+                              <m:t>=1</m:t>
                             </m:r>
                           </m:sub>
                           <m:sup>
@@ -15101,13 +15065,7 @@
                           <a:rPr lang="pt-BR" sz="2400">
                             <a:latin typeface="Cambria Math"/>
                           </a:rPr>
-                          <m:t>−</m:t>
-                        </m:r>
-                        <m:r>
-                          <a:rPr lang="pt-BR" sz="2400">
-                            <a:latin typeface="Cambria Math"/>
-                          </a:rPr>
-                          <m:t>1</m:t>
+                          <m:t>−1</m:t>
                         </m:r>
                       </m:den>
                     </m:f>
@@ -15265,144 +15223,53 @@
                 </a:r>
                 <a:r>
                   <a:rPr sz="2400"/>
-                  <a:t> (Aula 19).</a:t>
+                  <a:t> (Aula </a:t>
+                </a:r>
+                <a:r>
+                  <a:rPr lang="pt-BR" sz="2400"/>
+                  <a:t>18</a:t>
+                </a:r>
+                <a:r>
+                  <a:rPr sz="2400"/>
+                  <a:t>).</a:t>
                 </a:r>
               </a:p>
             </p:txBody>
           </p:sp>
         </mc:Choice>
-        <mc:Fallback xmlns="">
-          <p:sp xmlns:a14="http://schemas.microsoft.com/office/drawing/2010/main">
+        <mc:Fallback>
+          <p:sp>
             <p:nvSpPr>
               <p:cNvPr id="4" name="TextBox 3"/>
-              <p:cNvSpPr txBox="1"/>
+              <p:cNvSpPr txBox="1">
+                <a:spLocks noRot="1" noChangeAspect="1" noMove="1" noResize="1" noEditPoints="1" noAdjustHandles="1" noChangeArrowheads="1" noChangeShapeType="1" noTextEdit="1"/>
+              </p:cNvSpPr>
               <p:nvPr/>
             </p:nvSpPr>
             <p:spPr>
               <a:xfrm>
                 <a:off x="729287" y="467833"/>
-                <a:ext cx="10733426" cy="5900000"/>
+                <a:ext cx="10733426" cy="4277838"/>
               </a:xfrm>
               <a:prstGeom prst="rect">
                 <a:avLst/>
               </a:prstGeom>
-              <a:noFill/>
+              <a:blipFill>
+                <a:blip r:embed="rId2"/>
+                <a:stretch>
+                  <a:fillRect l="-909" b="-2425"/>
+                </a:stretch>
+              </a:blipFill>
             </p:spPr>
             <p:txBody>
-              <a:bodyPr wrap="square">
-                <a:spAutoFit/>
-              </a:bodyPr>
+              <a:bodyPr/>
               <a:lstStyle/>
               <a:p>
-                <a:pPr>
-                  <a:lnSpc>
-                    <a:spcPct val="150000"/>
-                  </a:lnSpc>
-                </a:pPr>
-                <a:r>
-                  <a:rPr sz="2400" b="1"/>
-                  <a:t>Resumo da aula</a:t>
-                </a:r>
-              </a:p>
-              <a:p>
-                <a:pPr marL="342900" indent="-342900">
-                  <a:lnSpc>
-                    <a:spcPct val="150000"/>
-                  </a:lnSpc>
-                  <a:buFont typeface="Arial"/>
-                  <a:buChar char="•"/>
-                </a:pPr>
-                <a:r>
-                  <a:rPr sz="2400" b="1"/>
-                  <a:t>Variância amostral: </a:t>
-                </a:r>
-                <a:r>
-                  <a:rPr sz="2400"/>
-                  <a:t>.</a:t>
-                </a:r>
-              </a:p>
-              <a:p>
-                <a:pPr marL="342900" indent="-342900">
-                  <a:lnSpc>
-                    <a:spcPct val="150000"/>
-                  </a:lnSpc>
-                  <a:buFont typeface="Arial"/>
-                  <a:buChar char="•"/>
-                </a:pPr>
-                <a:r>
-                  <a:rPr sz="2400" b="1"/>
-                  <a:t>Não viesado: </a:t>
-                </a:r>
-                <a:r>
-                  <a:rPr sz="2400"/>
-                  <a:t>em média, acerta o parâmetro: </a:t>
-                </a:r>
-                <a:r>
-                  <a:rPr sz="2400"/>
-                  <a:t>.</a:t>
-                </a:r>
-              </a:p>
-              <a:p>
-                <a:pPr marL="342900" indent="-342900">
-                  <a:lnSpc>
-                    <a:spcPct val="150000"/>
-                  </a:lnSpc>
-                  <a:buFont typeface="Arial"/>
-                  <a:buChar char="•"/>
-                </a:pPr>
-                <a:r>
-                  <a:rPr sz="2400" b="1"/>
-                  <a:t>Consistente: </a:t>
-                </a:r>
-                <a:r>
-                  <a:rPr sz="2400"/>
-                  <a:t>fica mais perto de </a:t>
-                </a:r>
-                <a:r>
-                  <a:rPr sz="2400"/>
-                  <a:t> quando </a:t>
-                </a:r>
-                <a:r>
-                  <a:rPr sz="2400"/>
-                  <a:t> cresce.</a:t>
-                </a:r>
-              </a:p>
-              <a:p>
-                <a:pPr marL="342900" indent="-342900">
-                  <a:lnSpc>
-                    <a:spcPct val="150000"/>
-                  </a:lnSpc>
-                  <a:buFont typeface="Arial"/>
-                  <a:buChar char="•"/>
-                </a:pPr>
-                <a:r>
-                  <a:rPr sz="2400" b="1"/>
-                  <a:t>Mais eficiente: </a:t>
-                </a:r>
-                <a:r>
-                  <a:rPr sz="2400"/>
-                  <a:t>entre os não viesados, é o de menor variância.</a:t>
-                </a:r>
-              </a:p>
-              <a:p>
-                <a:pPr marL="342900" indent="-342900">
-                  <a:lnSpc>
-                    <a:spcPct val="150000"/>
-                  </a:lnSpc>
-                  <a:buFont typeface="Arial"/>
-                  <a:buChar char="•"/>
-                </a:pPr>
-                <a:r>
-                  <a:rPr sz="2400"/>
-                  <a:t>Uma estimativa pontual não informa o tamanho do erro. Isso será feito com o </a:t>
-                </a:r>
-                <a:r>
-                  <a:rPr sz="2400" b="1"/>
-                  <a:t>intervalo de confiança</a:t>
-                </a:r>
-                <a:r>
-                  <a:rPr sz="2400"/>
-                  <a:t> (Aula 19).</a:t>
+                <a:r>
+                  <a:rPr lang="pt-BR">
+                    <a:noFill/>
+                  </a:rPr>
+                  <a:t> </a:t>
                 </a:r>
               </a:p>
             </p:txBody>
@@ -19121,8 +18988,8 @@
           </a:p>
         </p:txBody>
       </p:sp>
-      <mc:AlternateContent xmlns:mc="http://schemas.openxmlformats.org/markup-compatibility/2006">
-        <mc:Choice xmlns:a14="http://schemas.microsoft.com/office/drawing/2010/main" Requires="a14">
+      <mc:AlternateContent xmlns:mc="http://schemas.openxmlformats.org/markup-compatibility/2006" xmlns:a14="http://schemas.microsoft.com/office/drawing/2010/main">
+        <mc:Choice Requires="a14">
           <p:sp>
             <p:nvSpPr>
               <p:cNvPr id="4" name="TextBox 3"/>
@@ -19204,7 +19071,7 @@
                       <m:accPr>
                         <m:chr m:val="̂"/>
                         <m:ctrlPr>
-                          <a:rPr lang="pt-BR" sz="2400">
+                          <a:rPr lang="pt-BR" sz="2400" i="1">
                             <a:latin typeface="Cambria Math" panose="02040503050406030204" pitchFamily="18" charset="0"/>
                           </a:rPr>
                         </m:ctrlPr>
@@ -19334,7 +19201,7 @@
                       <m:accPr>
                         <m:chr m:val="̂"/>
                         <m:ctrlPr>
-                          <a:rPr lang="pt-BR" sz="2400">
+                          <a:rPr lang="pt-BR" sz="2400" i="1">
                             <a:latin typeface="Cambria Math" panose="02040503050406030204" pitchFamily="18" charset="0"/>
                           </a:rPr>
                         </m:ctrlPr>
@@ -19769,7 +19636,7 @@
             </p:txBody>
           </p:sp>
         </mc:Choice>
-        <mc:Fallback>
+        <mc:Fallback xmlns="">
           <p:sp>
             <p:nvSpPr>
               <p:cNvPr id="4" name="TextBox 3"/>

</xml_diff>